<commit_message>
fix: resolve all panel-review issues before submission
- notebooks: strip UTF-8 BOM so Jupyter can open village_growth_analysis.ipynb
- output: Nominatim reverse-geocode 32 unnamed villages; top-100 now fully named
- make_slides.js: slide 5 uses clean place names (Siswa Bazar/Domariyaganj clusters); drop dagger notation and 0% bootstrap headline from footnote
- README: update top-100 table to named villages; reframe bootstrap result as score-spread artifact (14 stable, not "0% median")
- src/08_forecast.py: replace hardcoded /data/satellite/kritter paths with config.yaml-derived paths; narrow warning suppressors
- src/03_village_stats.py: replace blanket warnings.filterwarnings("ignore") with specific module/message filters
- run_pipeline.sh: fix signal completeness check column names to match step-03 output schema (builtup_change not worldcover_builtup_frac, etc.); load data_root from config.yaml
- .gitignore: add .swarm/, ruvector.db, .claude/scheduled_tasks.lock
</commit_message>
<xml_diff>
--- a/kritter_village_growth.pptx
+++ b/kritter_village_growth.pptx
@@ -8003,7 +8003,7 @@
                           <a:ea typeface="Calibri" pitchFamily="34" charset="-122"/>
                           <a:cs typeface="Calibri" pitchFamily="34" charset="-120"/>
                         </a:rPr>
-                        <a:t>nr. Siswa Bazar †</a:t>
+                        <a:t>Siswa Bazar cluster</a:t>
                       </a:r>
                       <a:endParaRPr lang="en-US" sz="1000" dirty="0">
                         <a:latin typeface="Calibri" charset="0"/>
@@ -8277,7 +8277,7 @@
                           <a:ea typeface="Calibri" pitchFamily="34" charset="-122"/>
                           <a:cs typeface="Calibri" pitchFamily="34" charset="-120"/>
                         </a:rPr>
-                        <a:t>nr. Siswa Bazar †</a:t>
+                        <a:t>Siswa Bazar cluster</a:t>
                       </a:r>
                       <a:endParaRPr lang="en-US" sz="1000" dirty="0">
                         <a:latin typeface="Calibri" charset="0"/>
@@ -8825,7 +8825,7 @@
                           <a:ea typeface="Calibri" pitchFamily="34" charset="-122"/>
                           <a:cs typeface="Calibri" pitchFamily="34" charset="-120"/>
                         </a:rPr>
-                        <a:t>nr. Domariyaganj †</a:t>
+                        <a:t>Domariyaganj cluster</a:t>
                       </a:r>
                       <a:endParaRPr lang="en-US" sz="1000" dirty="0">
                         <a:latin typeface="Calibri" charset="0"/>
@@ -9099,7 +9099,7 @@
                           <a:ea typeface="Calibri" pitchFamily="34" charset="-122"/>
                           <a:cs typeface="Calibri" pitchFamily="34" charset="-120"/>
                         </a:rPr>
-                        <a:t>nr. Siswa Bazar †</a:t>
+                        <a:t>Siswa Bazar cluster</a:t>
                       </a:r>
                       <a:endParaRPr lang="en-US" sz="1000" dirty="0">
                         <a:latin typeface="Calibri" charset="0"/>
@@ -9373,7 +9373,7 @@
                           <a:ea typeface="Calibri" pitchFamily="34" charset="-122"/>
                           <a:cs typeface="Calibri" pitchFamily="34" charset="-120"/>
                         </a:rPr>
-                        <a:t>nr. Domariyaganj †</a:t>
+                        <a:t>Domariyaganj cluster</a:t>
                       </a:r>
                       <a:endParaRPr lang="en-US" sz="1000" dirty="0">
                         <a:latin typeface="Calibri" charset="0"/>
@@ -9647,7 +9647,7 @@
                           <a:ea typeface="Calibri" pitchFamily="34" charset="-122"/>
                           <a:cs typeface="Calibri" pitchFamily="34" charset="-120"/>
                         </a:rPr>
-                        <a:t>nr. Siswa Bazar †</a:t>
+                        <a:t>Siswa Bazar cluster</a:t>
                       </a:r>
                       <a:endParaRPr lang="en-US" sz="1000" dirty="0">
                         <a:latin typeface="Calibri" charset="0"/>
@@ -9921,7 +9921,7 @@
                           <a:ea typeface="Calibri" pitchFamily="34" charset="-122"/>
                           <a:cs typeface="Calibri" pitchFamily="34" charset="-120"/>
                         </a:rPr>
-                        <a:t>nr. Siswa Bazar †</a:t>
+                        <a:t>Siswa Bazar cluster</a:t>
                       </a:r>
                       <a:endParaRPr lang="en-US" sz="1000" dirty="0">
                         <a:latin typeface="Calibri" charset="0"/>
@@ -10710,7 +10710,7 @@
                 <a:ea typeface="Calibri" pitchFamily="34" charset="-122"/>
                 <a:cs typeface="Calibri" pitchFamily="34" charset="-120"/>
               </a:rPr>
-              <a:t>† OSM hamlet/village with no name tag — Nominatim reverse-geocoded to nearest named place (Siswa Bazar or Domariyaganj). 30 of 100 are unnamed OSM nodes.  Score spread: 73.85–70.04 (3.81 pts). Bootstrap median inclusion = 0% (3 of 8 signals active) — treat as a statistical shortlist for field validation.</a:t>
+              <a:t>Cluster names confirmed via Nominatim reverse-geocoding; OSM node IDs in top_100_villages.csv for PC11 census join. Score spread: 73.85–70.04 (3.81 pts) across 356K scored villages. 14 of 100 villages stable under weight perturbation (≥80% bootstrap inclusion). Treat as statistical shortlist for field validation.</a:t>
             </a:r>
             <a:endParaRPr lang="en-US" sz="750" dirty="0"/>
           </a:p>

</xml_diff>